<commit_message>
Added lectures for shared memory
</commit_message>
<xml_diff>
--- a/units/unit08_sharedmem/sharedmem.pptx
+++ b/units/unit08_sharedmem/sharedmem.pptx
@@ -5,7 +5,7 @@
     <p:sldMasterId id="2147483648" r:id="rId1"/>
   </p:sldMasterIdLst>
   <p:notesMasterIdLst>
-    <p:notesMasterId r:id="rId40"/>
+    <p:notesMasterId r:id="rId49"/>
   </p:notesMasterIdLst>
   <p:sldIdLst>
     <p:sldId id="258" r:id="rId2"/>
@@ -46,6 +46,15 @@
     <p:sldId id="436" r:id="rId37"/>
     <p:sldId id="439" r:id="rId38"/>
     <p:sldId id="440" r:id="rId39"/>
+    <p:sldId id="441" r:id="rId40"/>
+    <p:sldId id="442" r:id="rId41"/>
+    <p:sldId id="443" r:id="rId42"/>
+    <p:sldId id="444" r:id="rId43"/>
+    <p:sldId id="445" r:id="rId44"/>
+    <p:sldId id="446" r:id="rId45"/>
+    <p:sldId id="447" r:id="rId46"/>
+    <p:sldId id="448" r:id="rId47"/>
+    <p:sldId id="449" r:id="rId48"/>
   </p:sldIdLst>
   <p:sldSz cx="12192000" cy="6858000"/>
   <p:notesSz cx="7315200" cy="9601200"/>
@@ -20110,6 +20119,172 @@
 </p:sld>
 </file>
 
+<file path=ppt/slides/slide39.xml><?xml version="1.0" encoding="utf-8"?>
+<p:sld xmlns:a="http://schemas.openxmlformats.org/drawingml/2006/main" xmlns:r="http://schemas.openxmlformats.org/officeDocument/2006/relationships" xmlns:p="http://schemas.openxmlformats.org/presentationml/2006/main">
+  <p:cSld>
+    <p:spTree>
+      <p:nvGrpSpPr>
+        <p:cNvPr id="1" name="">
+          <a:extLst>
+            <a:ext uri="{FF2B5EF4-FFF2-40B4-BE49-F238E27FC236}">
+              <a16:creationId xmlns:a16="http://schemas.microsoft.com/office/drawing/2014/main" id="{962A6489-95B2-1C25-1C49-62E86AD6C604}"/>
+            </a:ext>
+          </a:extLst>
+        </p:cNvPr>
+        <p:cNvGrpSpPr/>
+        <p:nvPr/>
+      </p:nvGrpSpPr>
+      <p:grpSpPr>
+        <a:xfrm>
+          <a:off x="0" y="0"/>
+          <a:ext cx="0" cy="0"/>
+          <a:chOff x="0" y="0"/>
+          <a:chExt cx="0" cy="0"/>
+        </a:xfrm>
+      </p:grpSpPr>
+      <p:sp>
+        <p:nvSpPr>
+          <p:cNvPr id="2" name="Title 1">
+            <a:extLst>
+              <a:ext uri="{FF2B5EF4-FFF2-40B4-BE49-F238E27FC236}">
+                <a16:creationId xmlns:a16="http://schemas.microsoft.com/office/drawing/2014/main" id="{265CF359-95A0-E292-651D-311EEFBABD54}"/>
+              </a:ext>
+            </a:extLst>
+          </p:cNvPr>
+          <p:cNvSpPr>
+            <a:spLocks noGrp="1"/>
+          </p:cNvSpPr>
+          <p:nvPr>
+            <p:ph type="title"/>
+          </p:nvPr>
+        </p:nvSpPr>
+        <p:spPr/>
+        <p:txBody>
+          <a:bodyPr/>
+          <a:lstStyle/>
+          <a:p>
+            <a:r>
+              <a:rPr lang="en-US" dirty="0"/>
+              <a:t>BRAM TB</a:t>
+            </a:r>
+          </a:p>
+        </p:txBody>
+      </p:sp>
+      <p:sp>
+        <p:nvSpPr>
+          <p:cNvPr id="3" name="Content Placeholder 2">
+            <a:extLst>
+              <a:ext uri="{FF2B5EF4-FFF2-40B4-BE49-F238E27FC236}">
+                <a16:creationId xmlns:a16="http://schemas.microsoft.com/office/drawing/2014/main" id="{E655D11F-33B3-BEFA-84D2-A0280F6462C1}"/>
+              </a:ext>
+            </a:extLst>
+          </p:cNvPr>
+          <p:cNvSpPr>
+            <a:spLocks noGrp="1"/>
+          </p:cNvSpPr>
+          <p:nvPr>
+            <p:ph idx="1"/>
+          </p:nvPr>
+        </p:nvSpPr>
+        <p:spPr>
+          <a:xfrm>
+            <a:off x="1097280" y="1539277"/>
+            <a:ext cx="4058920" cy="4329817"/>
+          </a:xfrm>
+        </p:spPr>
+        <p:txBody>
+          <a:bodyPr/>
+          <a:lstStyle/>
+          <a:p>
+            <a:r>
+              <a:rPr lang="en-US" dirty="0"/>
+              <a:t>Creates BRAM emulation</a:t>
+            </a:r>
+          </a:p>
+          <a:p>
+            <a:pPr lvl="1"/>
+            <a:r>
+              <a:rPr lang="en-US" dirty="0"/>
+              <a:t>Or actual memory</a:t>
+            </a:r>
+          </a:p>
+          <a:p>
+            <a:endParaRPr lang="en-US" dirty="0"/>
+          </a:p>
+        </p:txBody>
+      </p:sp>
+      <p:sp>
+        <p:nvSpPr>
+          <p:cNvPr id="4" name="Slide Number Placeholder 3">
+            <a:extLst>
+              <a:ext uri="{FF2B5EF4-FFF2-40B4-BE49-F238E27FC236}">
+                <a16:creationId xmlns:a16="http://schemas.microsoft.com/office/drawing/2014/main" id="{1E1D8769-FCB4-F067-DE5F-D4F2A2561968}"/>
+              </a:ext>
+            </a:extLst>
+          </p:cNvPr>
+          <p:cNvSpPr>
+            <a:spLocks noGrp="1"/>
+          </p:cNvSpPr>
+          <p:nvPr>
+            <p:ph type="sldNum" sz="quarter" idx="12"/>
+          </p:nvPr>
+        </p:nvSpPr>
+        <p:spPr/>
+        <p:txBody>
+          <a:bodyPr/>
+          <a:lstStyle/>
+          <a:p>
+            <a:fld id="{629637A9-119A-49DA-BD12-AAC58B377D80}" type="slidenum">
+              <a:rPr lang="en-US" smtClean="0"/>
+              <a:t>39</a:t>
+            </a:fld>
+            <a:endParaRPr lang="en-US" dirty="0"/>
+          </a:p>
+        </p:txBody>
+      </p:sp>
+      <p:pic>
+        <p:nvPicPr>
+          <p:cNvPr id="6" name="Picture 5">
+            <a:extLst>
+              <a:ext uri="{FF2B5EF4-FFF2-40B4-BE49-F238E27FC236}">
+                <a16:creationId xmlns:a16="http://schemas.microsoft.com/office/drawing/2014/main" id="{6B65B442-3EC0-015F-734C-9C8629CB0772}"/>
+              </a:ext>
+            </a:extLst>
+          </p:cNvPr>
+          <p:cNvPicPr>
+            <a:picLocks noChangeAspect="1"/>
+          </p:cNvPicPr>
+          <p:nvPr/>
+        </p:nvPicPr>
+        <p:blipFill>
+          <a:blip r:embed="rId2"/>
+          <a:stretch>
+            <a:fillRect/>
+          </a:stretch>
+        </p:blipFill>
+        <p:spPr>
+          <a:xfrm>
+            <a:off x="6429012" y="912563"/>
+            <a:ext cx="5201376" cy="3572374"/>
+          </a:xfrm>
+          <a:prstGeom prst="rect">
+            <a:avLst/>
+          </a:prstGeom>
+        </p:spPr>
+      </p:pic>
+    </p:spTree>
+    <p:extLst>
+      <p:ext uri="{BB962C8B-B14F-4D97-AF65-F5344CB8AC3E}">
+        <p14:creationId xmlns:p14="http://schemas.microsoft.com/office/powerpoint/2010/main" val="2937947446"/>
+      </p:ext>
+    </p:extLst>
+  </p:cSld>
+  <p:clrMapOvr>
+    <a:masterClrMapping/>
+  </p:clrMapOvr>
+</p:sld>
+</file>
+
 <file path=ppt/slides/slide4.xml><?xml version="1.0" encoding="utf-8"?>
 <p:sld xmlns:a="http://schemas.openxmlformats.org/drawingml/2006/main" xmlns:r="http://schemas.openxmlformats.org/officeDocument/2006/relationships" xmlns:p="http://schemas.openxmlformats.org/presentationml/2006/main">
   <p:cSld>
@@ -21667,6 +21842,1608 @@
     <p:extLst>
       <p:ext uri="{BB962C8B-B14F-4D97-AF65-F5344CB8AC3E}">
         <p14:creationId xmlns:p14="http://schemas.microsoft.com/office/powerpoint/2010/main" val="2852746629"/>
+      </p:ext>
+    </p:extLst>
+  </p:cSld>
+  <p:clrMapOvr>
+    <a:masterClrMapping/>
+  </p:clrMapOvr>
+</p:sld>
+</file>
+
+<file path=ppt/slides/slide40.xml><?xml version="1.0" encoding="utf-8"?>
+<p:sld xmlns:a="http://schemas.openxmlformats.org/drawingml/2006/main" xmlns:r="http://schemas.openxmlformats.org/officeDocument/2006/relationships" xmlns:p="http://schemas.openxmlformats.org/presentationml/2006/main">
+  <p:cSld>
+    <p:spTree>
+      <p:nvGrpSpPr>
+        <p:cNvPr id="1" name=""/>
+        <p:cNvGrpSpPr/>
+        <p:nvPr/>
+      </p:nvGrpSpPr>
+      <p:grpSpPr>
+        <a:xfrm>
+          <a:off x="0" y="0"/>
+          <a:ext cx="0" cy="0"/>
+          <a:chOff x="0" y="0"/>
+          <a:chExt cx="0" cy="0"/>
+        </a:xfrm>
+      </p:grpSpPr>
+      <p:sp>
+        <p:nvSpPr>
+          <p:cNvPr id="2" name="Title 1">
+            <a:extLst>
+              <a:ext uri="{FF2B5EF4-FFF2-40B4-BE49-F238E27FC236}">
+                <a16:creationId xmlns:a16="http://schemas.microsoft.com/office/drawing/2014/main" id="{299500A5-B8C2-6C0F-EBA5-2990726D5BE5}"/>
+              </a:ext>
+            </a:extLst>
+          </p:cNvPr>
+          <p:cNvSpPr>
+            <a:spLocks noGrp="1"/>
+          </p:cNvSpPr>
+          <p:nvPr>
+            <p:ph type="title"/>
+          </p:nvPr>
+        </p:nvSpPr>
+        <p:spPr/>
+        <p:txBody>
+          <a:bodyPr/>
+          <a:lstStyle/>
+          <a:p>
+            <a:r>
+              <a:rPr lang="en-US" dirty="0"/>
+              <a:t>AXI4 Histogram Example</a:t>
+            </a:r>
+          </a:p>
+        </p:txBody>
+      </p:sp>
+      <mc:AlternateContent xmlns:mc="http://schemas.openxmlformats.org/markup-compatibility/2006">
+        <mc:Choice xmlns:a14="http://schemas.microsoft.com/office/drawing/2010/main" Requires="a14">
+          <p:sp>
+            <p:nvSpPr>
+              <p:cNvPr id="3" name="Content Placeholder 2">
+                <a:extLst>
+                  <a:ext uri="{FF2B5EF4-FFF2-40B4-BE49-F238E27FC236}">
+                    <a16:creationId xmlns:a16="http://schemas.microsoft.com/office/drawing/2014/main" id="{1F2EB5A2-787F-194C-2EC1-E5643B89B6C7}"/>
+                  </a:ext>
+                </a:extLst>
+              </p:cNvPr>
+              <p:cNvSpPr>
+                <a:spLocks noGrp="1"/>
+              </p:cNvSpPr>
+              <p:nvPr>
+                <p:ph idx="1"/>
+              </p:nvPr>
+            </p:nvSpPr>
+            <p:spPr>
+              <a:xfrm>
+                <a:off x="1097280" y="1539277"/>
+                <a:ext cx="4735402" cy="4329817"/>
+              </a:xfrm>
+            </p:spPr>
+            <p:txBody>
+              <a:bodyPr/>
+              <a:lstStyle/>
+              <a:p>
+                <a:r>
+                  <a:rPr lang="en-US" dirty="0"/>
+                  <a:t>Non-uniform histogram</a:t>
+                </a:r>
+              </a:p>
+              <a:p>
+                <a:r>
+                  <a:rPr lang="en-US" dirty="0"/>
+                  <a:t>Given:</a:t>
+                </a:r>
+              </a:p>
+              <a:p>
+                <a:pPr lvl="1"/>
+                <a:r>
+                  <a:rPr lang="en-US" dirty="0"/>
+                  <a:t> </a:t>
+                </a:r>
+                <a14:m>
+                  <m:oMath xmlns:m="http://schemas.openxmlformats.org/officeDocument/2006/math">
+                    <m:r>
+                      <a:rPr lang="en-US" b="0" i="1" smtClean="0">
+                        <a:latin typeface="Cambria Math" panose="02040503050406030204" pitchFamily="18" charset="0"/>
+                      </a:rPr>
+                      <m:t>𝑁</m:t>
+                    </m:r>
+                  </m:oMath>
+                </a14:m>
+                <a:r>
+                  <a:rPr lang="en-US" dirty="0"/>
+                  <a:t> data values </a:t>
+                </a:r>
+                <a14:m>
+                  <m:oMath xmlns:m="http://schemas.openxmlformats.org/officeDocument/2006/math">
+                    <m:r>
+                      <a:rPr lang="en-US" b="0" i="1" smtClean="0">
+                        <a:latin typeface="Cambria Math" panose="02040503050406030204" pitchFamily="18" charset="0"/>
+                      </a:rPr>
+                      <m:t>𝑑𝑎𝑡𝑎</m:t>
+                    </m:r>
+                    <m:r>
+                      <a:rPr lang="en-US" b="0" i="1" smtClean="0">
+                        <a:latin typeface="Cambria Math" panose="02040503050406030204" pitchFamily="18" charset="0"/>
+                      </a:rPr>
+                      <m:t>[</m:t>
+                    </m:r>
+                    <m:r>
+                      <a:rPr lang="en-US" b="0" i="1" smtClean="0">
+                        <a:latin typeface="Cambria Math" panose="02040503050406030204" pitchFamily="18" charset="0"/>
+                      </a:rPr>
+                      <m:t>𝑖</m:t>
+                    </m:r>
+                    <m:r>
+                      <a:rPr lang="en-US" b="0" i="1" smtClean="0">
+                        <a:latin typeface="Cambria Math" panose="02040503050406030204" pitchFamily="18" charset="0"/>
+                      </a:rPr>
+                      <m:t>]</m:t>
+                    </m:r>
+                  </m:oMath>
+                </a14:m>
+                <a:endParaRPr lang="en-US" dirty="0"/>
+              </a:p>
+              <a:p>
+                <a:pPr lvl="1"/>
+                <a14:m>
+                  <m:oMath xmlns:m="http://schemas.openxmlformats.org/officeDocument/2006/math">
+                    <m:r>
+                      <a:rPr lang="en-US" b="0" i="1" smtClean="0">
+                        <a:latin typeface="Cambria Math" panose="02040503050406030204" pitchFamily="18" charset="0"/>
+                      </a:rPr>
+                      <m:t>𝐵</m:t>
+                    </m:r>
+                  </m:oMath>
+                </a14:m>
+                <a:r>
+                  <a:rPr lang="en-US" dirty="0"/>
+                  <a:t> bin edges </a:t>
+                </a:r>
+                <a14:m>
+                  <m:oMath xmlns:m="http://schemas.openxmlformats.org/officeDocument/2006/math">
+                    <m:r>
+                      <a:rPr lang="en-US" b="0" i="1" smtClean="0">
+                        <a:latin typeface="Cambria Math" panose="02040503050406030204" pitchFamily="18" charset="0"/>
+                      </a:rPr>
+                      <m:t>𝑏𝑖𝑛</m:t>
+                    </m:r>
+                    <m:r>
+                      <a:rPr lang="en-US" b="0" i="1" smtClean="0">
+                        <a:latin typeface="Cambria Math" panose="02040503050406030204" pitchFamily="18" charset="0"/>
+                      </a:rPr>
+                      <m:t>_</m:t>
+                    </m:r>
+                    <m:r>
+                      <a:rPr lang="en-US" b="0" i="1" smtClean="0">
+                        <a:latin typeface="Cambria Math" panose="02040503050406030204" pitchFamily="18" charset="0"/>
+                      </a:rPr>
+                      <m:t>𝑒𝑑𝑔𝑒𝑠</m:t>
+                    </m:r>
+                    <m:r>
+                      <a:rPr lang="en-US" b="0" i="1" smtClean="0">
+                        <a:latin typeface="Cambria Math" panose="02040503050406030204" pitchFamily="18" charset="0"/>
+                      </a:rPr>
+                      <m:t>[</m:t>
+                    </m:r>
+                    <m:r>
+                      <a:rPr lang="en-US" b="0" i="1" smtClean="0">
+                        <a:latin typeface="Cambria Math" panose="02040503050406030204" pitchFamily="18" charset="0"/>
+                      </a:rPr>
+                      <m:t>𝑗</m:t>
+                    </m:r>
+                    <m:r>
+                      <a:rPr lang="en-US" b="0" i="1" smtClean="0">
+                        <a:latin typeface="Cambria Math" panose="02040503050406030204" pitchFamily="18" charset="0"/>
+                      </a:rPr>
+                      <m:t>]</m:t>
+                    </m:r>
+                  </m:oMath>
+                </a14:m>
+                <a:endParaRPr lang="en-US" dirty="0"/>
+              </a:p>
+              <a:p>
+                <a:r>
+                  <a:rPr lang="en-US" dirty="0"/>
+                  <a:t>Compute</a:t>
+                </a:r>
+              </a:p>
+              <a:p>
+                <a:pPr lvl="1"/>
+                <a14:m>
+                  <m:oMath xmlns:m="http://schemas.openxmlformats.org/officeDocument/2006/math">
+                    <m:r>
+                      <a:rPr lang="en-US" b="0" i="1" smtClean="0">
+                        <a:latin typeface="Cambria Math" panose="02040503050406030204" pitchFamily="18" charset="0"/>
+                      </a:rPr>
+                      <m:t>𝑐𝑜𝑢𝑛𝑡𝑠</m:t>
+                    </m:r>
+                    <m:r>
+                      <a:rPr lang="en-US" b="0" i="1" smtClean="0">
+                        <a:latin typeface="Cambria Math" panose="02040503050406030204" pitchFamily="18" charset="0"/>
+                      </a:rPr>
+                      <m:t>[</m:t>
+                    </m:r>
+                    <m:r>
+                      <a:rPr lang="en-US" b="0" i="1" smtClean="0">
+                        <a:latin typeface="Cambria Math" panose="02040503050406030204" pitchFamily="18" charset="0"/>
+                      </a:rPr>
+                      <m:t>𝑗</m:t>
+                    </m:r>
+                    <m:r>
+                      <a:rPr lang="en-US" b="0" i="1" smtClean="0">
+                        <a:latin typeface="Cambria Math" panose="02040503050406030204" pitchFamily="18" charset="0"/>
+                      </a:rPr>
+                      <m:t>]</m:t>
+                    </m:r>
+                  </m:oMath>
+                </a14:m>
+                <a:r>
+                  <a:rPr lang="en-US" dirty="0"/>
+                  <a:t>,  </a:t>
+                </a:r>
+                <a14:m>
+                  <m:oMath xmlns:m="http://schemas.openxmlformats.org/officeDocument/2006/math">
+                    <m:r>
+                      <a:rPr lang="en-US" b="0" i="1" dirty="0" smtClean="0">
+                        <a:latin typeface="Cambria Math" panose="02040503050406030204" pitchFamily="18" charset="0"/>
+                      </a:rPr>
+                      <m:t>𝑗</m:t>
+                    </m:r>
+                    <m:r>
+                      <a:rPr lang="en-US" b="0" i="1" dirty="0" smtClean="0">
+                        <a:latin typeface="Cambria Math" panose="02040503050406030204" pitchFamily="18" charset="0"/>
+                      </a:rPr>
+                      <m:t>=0,…, </m:t>
+                    </m:r>
+                    <m:r>
+                      <a:rPr lang="en-US" b="0" i="1" dirty="0" smtClean="0">
+                        <a:latin typeface="Cambria Math" panose="02040503050406030204" pitchFamily="18" charset="0"/>
+                      </a:rPr>
+                      <m:t>𝐵</m:t>
+                    </m:r>
+                  </m:oMath>
+                </a14:m>
+                <a:endParaRPr lang="en-US" dirty="0"/>
+              </a:p>
+              <a:p>
+                <a:pPr lvl="1"/>
+                <a:r>
+                  <a:rPr lang="en-US" dirty="0"/>
+                  <a:t>Includes underflow and overflow values</a:t>
+                </a:r>
+              </a:p>
+              <a:p>
+                <a:endParaRPr lang="en-US" dirty="0"/>
+              </a:p>
+            </p:txBody>
+          </p:sp>
+        </mc:Choice>
+        <mc:Fallback>
+          <p:sp>
+            <p:nvSpPr>
+              <p:cNvPr id="3" name="Content Placeholder 2">
+                <a:extLst>
+                  <a:ext uri="{FF2B5EF4-FFF2-40B4-BE49-F238E27FC236}">
+                    <a16:creationId xmlns:a16="http://schemas.microsoft.com/office/drawing/2014/main" id="{1F2EB5A2-787F-194C-2EC1-E5643B89B6C7}"/>
+                  </a:ext>
+                </a:extLst>
+              </p:cNvPr>
+              <p:cNvSpPr>
+                <a:spLocks noGrp="1" noRot="1" noChangeAspect="1" noMove="1" noResize="1" noEditPoints="1" noAdjustHandles="1" noChangeArrowheads="1" noChangeShapeType="1" noTextEdit="1"/>
+              </p:cNvSpPr>
+              <p:nvPr>
+                <p:ph idx="1"/>
+              </p:nvPr>
+            </p:nvSpPr>
+            <p:spPr>
+              <a:xfrm>
+                <a:off x="1097280" y="1539277"/>
+                <a:ext cx="4735402" cy="4329817"/>
+              </a:xfrm>
+              <a:blipFill>
+                <a:blip r:embed="rId2"/>
+                <a:stretch>
+                  <a:fillRect l="-3089" t="-1549"/>
+                </a:stretch>
+              </a:blipFill>
+            </p:spPr>
+            <p:txBody>
+              <a:bodyPr/>
+              <a:lstStyle/>
+              <a:p>
+                <a:r>
+                  <a:rPr lang="en-US">
+                    <a:noFill/>
+                  </a:rPr>
+                  <a:t> </a:t>
+                </a:r>
+              </a:p>
+            </p:txBody>
+          </p:sp>
+        </mc:Fallback>
+      </mc:AlternateContent>
+      <p:sp>
+        <p:nvSpPr>
+          <p:cNvPr id="4" name="Slide Number Placeholder 3">
+            <a:extLst>
+              <a:ext uri="{FF2B5EF4-FFF2-40B4-BE49-F238E27FC236}">
+                <a16:creationId xmlns:a16="http://schemas.microsoft.com/office/drawing/2014/main" id="{D800931E-5357-91D7-F833-1D1508D39B20}"/>
+              </a:ext>
+            </a:extLst>
+          </p:cNvPr>
+          <p:cNvSpPr>
+            <a:spLocks noGrp="1"/>
+          </p:cNvSpPr>
+          <p:nvPr>
+            <p:ph type="sldNum" sz="quarter" idx="12"/>
+          </p:nvPr>
+        </p:nvSpPr>
+        <p:spPr/>
+        <p:txBody>
+          <a:bodyPr/>
+          <a:lstStyle/>
+          <a:p>
+            <a:fld id="{629637A9-119A-49DA-BD12-AAC58B377D80}" type="slidenum">
+              <a:rPr lang="en-US" smtClean="0"/>
+              <a:t>40</a:t>
+            </a:fld>
+            <a:endParaRPr lang="en-US" dirty="0"/>
+          </a:p>
+        </p:txBody>
+      </p:sp>
+      <p:pic>
+        <p:nvPicPr>
+          <p:cNvPr id="6" name="Picture 5">
+            <a:extLst>
+              <a:ext uri="{FF2B5EF4-FFF2-40B4-BE49-F238E27FC236}">
+                <a16:creationId xmlns:a16="http://schemas.microsoft.com/office/drawing/2014/main" id="{9425525A-39E3-92EA-F055-3B86E7676906}"/>
+              </a:ext>
+            </a:extLst>
+          </p:cNvPr>
+          <p:cNvPicPr>
+            <a:picLocks noChangeAspect="1"/>
+          </p:cNvPicPr>
+          <p:nvPr/>
+        </p:nvPicPr>
+        <p:blipFill>
+          <a:blip r:embed="rId3"/>
+          <a:stretch>
+            <a:fillRect/>
+          </a:stretch>
+        </p:blipFill>
+        <p:spPr>
+          <a:xfrm>
+            <a:off x="5832682" y="1885612"/>
+            <a:ext cx="5438775" cy="4114800"/>
+          </a:xfrm>
+          <a:prstGeom prst="rect">
+            <a:avLst/>
+          </a:prstGeom>
+        </p:spPr>
+      </p:pic>
+    </p:spTree>
+    <p:extLst>
+      <p:ext uri="{BB962C8B-B14F-4D97-AF65-F5344CB8AC3E}">
+        <p14:creationId xmlns:p14="http://schemas.microsoft.com/office/powerpoint/2010/main" val="4113423486"/>
+      </p:ext>
+    </p:extLst>
+  </p:cSld>
+  <p:clrMapOvr>
+    <a:masterClrMapping/>
+  </p:clrMapOvr>
+</p:sld>
+</file>
+
+<file path=ppt/slides/slide41.xml><?xml version="1.0" encoding="utf-8"?>
+<p:sld xmlns:a="http://schemas.openxmlformats.org/drawingml/2006/main" xmlns:r="http://schemas.openxmlformats.org/officeDocument/2006/relationships" xmlns:p="http://schemas.openxmlformats.org/presentationml/2006/main">
+  <p:cSld>
+    <p:spTree>
+      <p:nvGrpSpPr>
+        <p:cNvPr id="1" name=""/>
+        <p:cNvGrpSpPr/>
+        <p:nvPr/>
+      </p:nvGrpSpPr>
+      <p:grpSpPr>
+        <a:xfrm>
+          <a:off x="0" y="0"/>
+          <a:ext cx="0" cy="0"/>
+          <a:chOff x="0" y="0"/>
+          <a:chExt cx="0" cy="0"/>
+        </a:xfrm>
+      </p:grpSpPr>
+      <p:sp>
+        <p:nvSpPr>
+          <p:cNvPr id="2" name="Title 1">
+            <a:extLst>
+              <a:ext uri="{FF2B5EF4-FFF2-40B4-BE49-F238E27FC236}">
+                <a16:creationId xmlns:a16="http://schemas.microsoft.com/office/drawing/2014/main" id="{D8E49D2D-814F-B153-79AD-4BE8EC7B0F8F}"/>
+              </a:ext>
+            </a:extLst>
+          </p:cNvPr>
+          <p:cNvSpPr>
+            <a:spLocks noGrp="1"/>
+          </p:cNvSpPr>
+          <p:nvPr>
+            <p:ph type="title"/>
+          </p:nvPr>
+        </p:nvSpPr>
+        <p:spPr/>
+        <p:txBody>
+          <a:bodyPr/>
+          <a:lstStyle/>
+          <a:p>
+            <a:r>
+              <a:rPr lang="en-US" dirty="0"/>
+              <a:t>Histogram Command Input</a:t>
+            </a:r>
+          </a:p>
+        </p:txBody>
+      </p:sp>
+      <p:sp>
+        <p:nvSpPr>
+          <p:cNvPr id="3" name="Content Placeholder 2">
+            <a:extLst>
+              <a:ext uri="{FF2B5EF4-FFF2-40B4-BE49-F238E27FC236}">
+                <a16:creationId xmlns:a16="http://schemas.microsoft.com/office/drawing/2014/main" id="{CA2D1F14-6C48-0375-B12E-F7F61338D49A}"/>
+              </a:ext>
+            </a:extLst>
+          </p:cNvPr>
+          <p:cNvSpPr>
+            <a:spLocks noGrp="1"/>
+          </p:cNvSpPr>
+          <p:nvPr>
+            <p:ph idx="1"/>
+          </p:nvPr>
+        </p:nvSpPr>
+        <p:spPr>
+          <a:xfrm>
+            <a:off x="1097280" y="1539277"/>
+            <a:ext cx="4535208" cy="4329817"/>
+          </a:xfrm>
+        </p:spPr>
+        <p:txBody>
+          <a:bodyPr/>
+          <a:lstStyle/>
+          <a:p>
+            <a:r>
+              <a:rPr lang="en-US" dirty="0"/>
+              <a:t>Gives input addresses:</a:t>
+            </a:r>
+          </a:p>
+          <a:p>
+            <a:pPr lvl="1"/>
+            <a:r>
+              <a:rPr lang="en-US" dirty="0"/>
+              <a:t>Data</a:t>
+            </a:r>
+          </a:p>
+          <a:p>
+            <a:pPr lvl="1"/>
+            <a:r>
+              <a:rPr lang="en-US" dirty="0"/>
+              <a:t>Bin edges</a:t>
+            </a:r>
+          </a:p>
+          <a:p>
+            <a:r>
+              <a:rPr lang="en-US" dirty="0"/>
+              <a:t>Output addresses</a:t>
+            </a:r>
+          </a:p>
+          <a:p>
+            <a:pPr lvl="1"/>
+            <a:r>
+              <a:rPr lang="en-US" dirty="0"/>
+              <a:t>Counts</a:t>
+            </a:r>
+          </a:p>
+          <a:p>
+            <a:r>
+              <a:rPr lang="en-US" dirty="0"/>
+              <a:t>Transaction IDs and lengths </a:t>
+            </a:r>
+          </a:p>
+        </p:txBody>
+      </p:sp>
+      <p:sp>
+        <p:nvSpPr>
+          <p:cNvPr id="4" name="Slide Number Placeholder 3">
+            <a:extLst>
+              <a:ext uri="{FF2B5EF4-FFF2-40B4-BE49-F238E27FC236}">
+                <a16:creationId xmlns:a16="http://schemas.microsoft.com/office/drawing/2014/main" id="{C7F47A0F-D882-28AD-149C-CAAA21704F80}"/>
+              </a:ext>
+            </a:extLst>
+          </p:cNvPr>
+          <p:cNvSpPr>
+            <a:spLocks noGrp="1"/>
+          </p:cNvSpPr>
+          <p:nvPr>
+            <p:ph type="sldNum" sz="quarter" idx="12"/>
+          </p:nvPr>
+        </p:nvSpPr>
+        <p:spPr/>
+        <p:txBody>
+          <a:bodyPr/>
+          <a:lstStyle/>
+          <a:p>
+            <a:fld id="{629637A9-119A-49DA-BD12-AAC58B377D80}" type="slidenum">
+              <a:rPr lang="en-US" smtClean="0"/>
+              <a:t>41</a:t>
+            </a:fld>
+            <a:endParaRPr lang="en-US" dirty="0"/>
+          </a:p>
+        </p:txBody>
+      </p:sp>
+      <p:pic>
+        <p:nvPicPr>
+          <p:cNvPr id="6" name="Picture 5">
+            <a:extLst>
+              <a:ext uri="{FF2B5EF4-FFF2-40B4-BE49-F238E27FC236}">
+                <a16:creationId xmlns:a16="http://schemas.microsoft.com/office/drawing/2014/main" id="{CF7404DE-06C6-202C-AB85-FEB811CB2F41}"/>
+              </a:ext>
+            </a:extLst>
+          </p:cNvPr>
+          <p:cNvPicPr>
+            <a:picLocks noChangeAspect="1"/>
+          </p:cNvPicPr>
+          <p:nvPr/>
+        </p:nvPicPr>
+        <p:blipFill>
+          <a:blip r:embed="rId2"/>
+          <a:stretch>
+            <a:fillRect/>
+          </a:stretch>
+        </p:blipFill>
+        <p:spPr>
+          <a:xfrm>
+            <a:off x="6176842" y="1499034"/>
+            <a:ext cx="4667490" cy="4410302"/>
+          </a:xfrm>
+          <a:prstGeom prst="rect">
+            <a:avLst/>
+          </a:prstGeom>
+        </p:spPr>
+      </p:pic>
+    </p:spTree>
+    <p:extLst>
+      <p:ext uri="{BB962C8B-B14F-4D97-AF65-F5344CB8AC3E}">
+        <p14:creationId xmlns:p14="http://schemas.microsoft.com/office/powerpoint/2010/main" val="1931690064"/>
+      </p:ext>
+    </p:extLst>
+  </p:cSld>
+  <p:clrMapOvr>
+    <a:masterClrMapping/>
+  </p:clrMapOvr>
+</p:sld>
+</file>
+
+<file path=ppt/slides/slide42.xml><?xml version="1.0" encoding="utf-8"?>
+<p:sld xmlns:a="http://schemas.openxmlformats.org/drawingml/2006/main" xmlns:r="http://schemas.openxmlformats.org/officeDocument/2006/relationships" xmlns:p="http://schemas.openxmlformats.org/presentationml/2006/main">
+  <p:cSld>
+    <p:spTree>
+      <p:nvGrpSpPr>
+        <p:cNvPr id="1" name=""/>
+        <p:cNvGrpSpPr/>
+        <p:nvPr/>
+      </p:nvGrpSpPr>
+      <p:grpSpPr>
+        <a:xfrm>
+          <a:off x="0" y="0"/>
+          <a:ext cx="0" cy="0"/>
+          <a:chOff x="0" y="0"/>
+          <a:chExt cx="0" cy="0"/>
+        </a:xfrm>
+      </p:grpSpPr>
+      <p:sp>
+        <p:nvSpPr>
+          <p:cNvPr id="2" name="Title 1">
+            <a:extLst>
+              <a:ext uri="{FF2B5EF4-FFF2-40B4-BE49-F238E27FC236}">
+                <a16:creationId xmlns:a16="http://schemas.microsoft.com/office/drawing/2014/main" id="{A9298F1A-57FC-4C8A-B044-4D98BE0BD47C}"/>
+              </a:ext>
+            </a:extLst>
+          </p:cNvPr>
+          <p:cNvSpPr>
+            <a:spLocks noGrp="1"/>
+          </p:cNvSpPr>
+          <p:nvPr>
+            <p:ph type="title"/>
+          </p:nvPr>
+        </p:nvSpPr>
+        <p:spPr/>
+        <p:txBody>
+          <a:bodyPr/>
+          <a:lstStyle/>
+          <a:p>
+            <a:r>
+              <a:rPr lang="en-US" dirty="0"/>
+              <a:t>Histogram Interface</a:t>
+            </a:r>
+          </a:p>
+        </p:txBody>
+      </p:sp>
+      <p:sp>
+        <p:nvSpPr>
+          <p:cNvPr id="3" name="Content Placeholder 2">
+            <a:extLst>
+              <a:ext uri="{FF2B5EF4-FFF2-40B4-BE49-F238E27FC236}">
+                <a16:creationId xmlns:a16="http://schemas.microsoft.com/office/drawing/2014/main" id="{6825120E-878A-E167-06B5-1DFEC87410B3}"/>
+              </a:ext>
+            </a:extLst>
+          </p:cNvPr>
+          <p:cNvSpPr>
+            <a:spLocks noGrp="1"/>
+          </p:cNvSpPr>
+          <p:nvPr>
+            <p:ph idx="1"/>
+          </p:nvPr>
+        </p:nvSpPr>
+        <p:spPr>
+          <a:xfrm>
+            <a:off x="1097280" y="1539277"/>
+            <a:ext cx="4816561" cy="4329817"/>
+          </a:xfrm>
+        </p:spPr>
+        <p:txBody>
+          <a:bodyPr/>
+          <a:lstStyle/>
+          <a:p>
+            <a:r>
+              <a:rPr lang="en-US" dirty="0"/>
+              <a:t>AXI4 streams</a:t>
+            </a:r>
+          </a:p>
+          <a:p>
+            <a:pPr lvl="1"/>
+            <a:r>
+              <a:rPr lang="en-US" dirty="0"/>
+              <a:t>For command and response</a:t>
+            </a:r>
+          </a:p>
+          <a:p>
+            <a:pPr lvl="1"/>
+            <a:r>
+              <a:rPr lang="en-US" dirty="0"/>
+              <a:t>These could have been memory-mapped</a:t>
+            </a:r>
+          </a:p>
+          <a:p>
+            <a:r>
+              <a:rPr lang="en-US" dirty="0"/>
+              <a:t>AXI4-Full access to memory</a:t>
+            </a:r>
+          </a:p>
+          <a:p>
+            <a:r>
+              <a:rPr lang="en-US" dirty="0"/>
+              <a:t>Read command from AXI4 stream</a:t>
+            </a:r>
+          </a:p>
+        </p:txBody>
+      </p:sp>
+      <p:sp>
+        <p:nvSpPr>
+          <p:cNvPr id="4" name="Slide Number Placeholder 3">
+            <a:extLst>
+              <a:ext uri="{FF2B5EF4-FFF2-40B4-BE49-F238E27FC236}">
+                <a16:creationId xmlns:a16="http://schemas.microsoft.com/office/drawing/2014/main" id="{971F1ECF-C18F-92F4-0643-BF35F93DC833}"/>
+              </a:ext>
+            </a:extLst>
+          </p:cNvPr>
+          <p:cNvSpPr>
+            <a:spLocks noGrp="1"/>
+          </p:cNvSpPr>
+          <p:nvPr>
+            <p:ph type="sldNum" sz="quarter" idx="12"/>
+          </p:nvPr>
+        </p:nvSpPr>
+        <p:spPr/>
+        <p:txBody>
+          <a:bodyPr/>
+          <a:lstStyle/>
+          <a:p>
+            <a:fld id="{629637A9-119A-49DA-BD12-AAC58B377D80}" type="slidenum">
+              <a:rPr lang="en-US" smtClean="0"/>
+              <a:t>42</a:t>
+            </a:fld>
+            <a:endParaRPr lang="en-US" dirty="0"/>
+          </a:p>
+        </p:txBody>
+      </p:sp>
+      <p:pic>
+        <p:nvPicPr>
+          <p:cNvPr id="6" name="Picture 5">
+            <a:extLst>
+              <a:ext uri="{FF2B5EF4-FFF2-40B4-BE49-F238E27FC236}">
+                <a16:creationId xmlns:a16="http://schemas.microsoft.com/office/drawing/2014/main" id="{B5A28CD1-2CF9-5F1D-29E9-6AD085AB5152}"/>
+              </a:ext>
+            </a:extLst>
+          </p:cNvPr>
+          <p:cNvPicPr>
+            <a:picLocks noChangeAspect="1"/>
+          </p:cNvPicPr>
+          <p:nvPr/>
+        </p:nvPicPr>
+        <p:blipFill>
+          <a:blip r:embed="rId2"/>
+          <a:stretch>
+            <a:fillRect/>
+          </a:stretch>
+        </p:blipFill>
+        <p:spPr>
+          <a:xfrm>
+            <a:off x="5807970" y="1418609"/>
+            <a:ext cx="6056349" cy="4329817"/>
+          </a:xfrm>
+          <a:prstGeom prst="rect">
+            <a:avLst/>
+          </a:prstGeom>
+        </p:spPr>
+      </p:pic>
+    </p:spTree>
+    <p:extLst>
+      <p:ext uri="{BB962C8B-B14F-4D97-AF65-F5344CB8AC3E}">
+        <p14:creationId xmlns:p14="http://schemas.microsoft.com/office/powerpoint/2010/main" val="2548810579"/>
+      </p:ext>
+    </p:extLst>
+  </p:cSld>
+  <p:clrMapOvr>
+    <a:masterClrMapping/>
+  </p:clrMapOvr>
+</p:sld>
+</file>
+
+<file path=ppt/slides/slide43.xml><?xml version="1.0" encoding="utf-8"?>
+<p:sld xmlns:a="http://schemas.openxmlformats.org/drawingml/2006/main" xmlns:r="http://schemas.openxmlformats.org/officeDocument/2006/relationships" xmlns:p="http://schemas.openxmlformats.org/presentationml/2006/main">
+  <p:cSld>
+    <p:spTree>
+      <p:nvGrpSpPr>
+        <p:cNvPr id="1" name="">
+          <a:extLst>
+            <a:ext uri="{FF2B5EF4-FFF2-40B4-BE49-F238E27FC236}">
+              <a16:creationId xmlns:a16="http://schemas.microsoft.com/office/drawing/2014/main" id="{B2E15AF9-AA3D-5F80-6DCC-212A868BB896}"/>
+            </a:ext>
+          </a:extLst>
+        </p:cNvPr>
+        <p:cNvGrpSpPr/>
+        <p:nvPr/>
+      </p:nvGrpSpPr>
+      <p:grpSpPr>
+        <a:xfrm>
+          <a:off x="0" y="0"/>
+          <a:ext cx="0" cy="0"/>
+          <a:chOff x="0" y="0"/>
+          <a:chExt cx="0" cy="0"/>
+        </a:xfrm>
+      </p:grpSpPr>
+      <p:sp>
+        <p:nvSpPr>
+          <p:cNvPr id="2" name="Title 1">
+            <a:extLst>
+              <a:ext uri="{FF2B5EF4-FFF2-40B4-BE49-F238E27FC236}">
+                <a16:creationId xmlns:a16="http://schemas.microsoft.com/office/drawing/2014/main" id="{5C39EE57-1A67-DFFC-CE1A-2F67599723B7}"/>
+              </a:ext>
+            </a:extLst>
+          </p:cNvPr>
+          <p:cNvSpPr>
+            <a:spLocks noGrp="1"/>
+          </p:cNvSpPr>
+          <p:nvPr>
+            <p:ph type="title"/>
+          </p:nvPr>
+        </p:nvSpPr>
+        <p:spPr/>
+        <p:txBody>
+          <a:bodyPr/>
+          <a:lstStyle/>
+          <a:p>
+            <a:r>
+              <a:rPr lang="en-US" dirty="0"/>
+              <a:t>Histogram Read Phase</a:t>
+            </a:r>
+          </a:p>
+        </p:txBody>
+      </p:sp>
+      <p:sp>
+        <p:nvSpPr>
+          <p:cNvPr id="3" name="Content Placeholder 2">
+            <a:extLst>
+              <a:ext uri="{FF2B5EF4-FFF2-40B4-BE49-F238E27FC236}">
+                <a16:creationId xmlns:a16="http://schemas.microsoft.com/office/drawing/2014/main" id="{5A0DEE58-AAFC-1DAE-2E6C-850C6E1D268F}"/>
+              </a:ext>
+            </a:extLst>
+          </p:cNvPr>
+          <p:cNvSpPr>
+            <a:spLocks noGrp="1"/>
+          </p:cNvSpPr>
+          <p:nvPr>
+            <p:ph idx="1"/>
+          </p:nvPr>
+        </p:nvSpPr>
+        <p:spPr>
+          <a:xfrm>
+            <a:off x="1097280" y="1539277"/>
+            <a:ext cx="4816561" cy="4329817"/>
+          </a:xfrm>
+        </p:spPr>
+        <p:txBody>
+          <a:bodyPr/>
+          <a:lstStyle/>
+          <a:p>
+            <a:r>
+              <a:rPr lang="en-US" dirty="0"/>
+              <a:t>Read data and bin edges to a local buffer</a:t>
+            </a:r>
+          </a:p>
+          <a:p>
+            <a:r>
+              <a:rPr lang="en-US" dirty="0"/>
+              <a:t>Local buffer is not strictly needed for data</a:t>
+            </a:r>
+          </a:p>
+          <a:p>
+            <a:pPr lvl="1"/>
+            <a:r>
+              <a:rPr lang="en-US" dirty="0"/>
+              <a:t>Easy to illustrate</a:t>
+            </a:r>
+          </a:p>
+        </p:txBody>
+      </p:sp>
+      <p:sp>
+        <p:nvSpPr>
+          <p:cNvPr id="4" name="Slide Number Placeholder 3">
+            <a:extLst>
+              <a:ext uri="{FF2B5EF4-FFF2-40B4-BE49-F238E27FC236}">
+                <a16:creationId xmlns:a16="http://schemas.microsoft.com/office/drawing/2014/main" id="{6DAF5614-C1AD-C732-2851-625C09D39CCA}"/>
+              </a:ext>
+            </a:extLst>
+          </p:cNvPr>
+          <p:cNvSpPr>
+            <a:spLocks noGrp="1"/>
+          </p:cNvSpPr>
+          <p:nvPr>
+            <p:ph type="sldNum" sz="quarter" idx="12"/>
+          </p:nvPr>
+        </p:nvSpPr>
+        <p:spPr/>
+        <p:txBody>
+          <a:bodyPr/>
+          <a:lstStyle/>
+          <a:p>
+            <a:fld id="{629637A9-119A-49DA-BD12-AAC58B377D80}" type="slidenum">
+              <a:rPr lang="en-US" smtClean="0"/>
+              <a:t>43</a:t>
+            </a:fld>
+            <a:endParaRPr lang="en-US" dirty="0"/>
+          </a:p>
+        </p:txBody>
+      </p:sp>
+      <p:pic>
+        <p:nvPicPr>
+          <p:cNvPr id="7" name="Picture 6">
+            <a:extLst>
+              <a:ext uri="{FF2B5EF4-FFF2-40B4-BE49-F238E27FC236}">
+                <a16:creationId xmlns:a16="http://schemas.microsoft.com/office/drawing/2014/main" id="{F6FCBF22-C3C0-225C-A2C3-D663C0DB292E}"/>
+              </a:ext>
+            </a:extLst>
+          </p:cNvPr>
+          <p:cNvPicPr>
+            <a:picLocks noChangeAspect="1"/>
+          </p:cNvPicPr>
+          <p:nvPr/>
+        </p:nvPicPr>
+        <p:blipFill>
+          <a:blip r:embed="rId2"/>
+          <a:stretch>
+            <a:fillRect/>
+          </a:stretch>
+        </p:blipFill>
+        <p:spPr>
+          <a:xfrm>
+            <a:off x="3962283" y="2925990"/>
+            <a:ext cx="7907602" cy="2771426"/>
+          </a:xfrm>
+          <a:prstGeom prst="rect">
+            <a:avLst/>
+          </a:prstGeom>
+        </p:spPr>
+      </p:pic>
+    </p:spTree>
+    <p:extLst>
+      <p:ext uri="{BB962C8B-B14F-4D97-AF65-F5344CB8AC3E}">
+        <p14:creationId xmlns:p14="http://schemas.microsoft.com/office/powerpoint/2010/main" val="4117198285"/>
+      </p:ext>
+    </p:extLst>
+  </p:cSld>
+  <p:clrMapOvr>
+    <a:masterClrMapping/>
+  </p:clrMapOvr>
+</p:sld>
+</file>
+
+<file path=ppt/slides/slide44.xml><?xml version="1.0" encoding="utf-8"?>
+<p:sld xmlns:a="http://schemas.openxmlformats.org/drawingml/2006/main" xmlns:r="http://schemas.openxmlformats.org/officeDocument/2006/relationships" xmlns:p="http://schemas.openxmlformats.org/presentationml/2006/main">
+  <p:cSld>
+    <p:spTree>
+      <p:nvGrpSpPr>
+        <p:cNvPr id="1" name=""/>
+        <p:cNvGrpSpPr/>
+        <p:nvPr/>
+      </p:nvGrpSpPr>
+      <p:grpSpPr>
+        <a:xfrm>
+          <a:off x="0" y="0"/>
+          <a:ext cx="0" cy="0"/>
+          <a:chOff x="0" y="0"/>
+          <a:chExt cx="0" cy="0"/>
+        </a:xfrm>
+      </p:grpSpPr>
+      <p:sp>
+        <p:nvSpPr>
+          <p:cNvPr id="2" name="Title 1">
+            <a:extLst>
+              <a:ext uri="{FF2B5EF4-FFF2-40B4-BE49-F238E27FC236}">
+                <a16:creationId xmlns:a16="http://schemas.microsoft.com/office/drawing/2014/main" id="{96469B64-4970-ECEB-85D0-2FAE22AD3671}"/>
+              </a:ext>
+            </a:extLst>
+          </p:cNvPr>
+          <p:cNvSpPr>
+            <a:spLocks noGrp="1"/>
+          </p:cNvSpPr>
+          <p:nvPr>
+            <p:ph type="title"/>
+          </p:nvPr>
+        </p:nvSpPr>
+        <p:spPr/>
+        <p:txBody>
+          <a:bodyPr/>
+          <a:lstStyle/>
+          <a:p>
+            <a:r>
+              <a:rPr lang="en-US" dirty="0"/>
+              <a:t>Core Histogram Loop</a:t>
+            </a:r>
+          </a:p>
+        </p:txBody>
+      </p:sp>
+      <p:sp>
+        <p:nvSpPr>
+          <p:cNvPr id="3" name="Content Placeholder 2">
+            <a:extLst>
+              <a:ext uri="{FF2B5EF4-FFF2-40B4-BE49-F238E27FC236}">
+                <a16:creationId xmlns:a16="http://schemas.microsoft.com/office/drawing/2014/main" id="{05A11F6A-BC3C-E2CB-EFC1-CA53D9F05EFF}"/>
+              </a:ext>
+            </a:extLst>
+          </p:cNvPr>
+          <p:cNvSpPr>
+            <a:spLocks noGrp="1"/>
+          </p:cNvSpPr>
+          <p:nvPr>
+            <p:ph idx="1"/>
+          </p:nvPr>
+        </p:nvSpPr>
+        <p:spPr>
+          <a:xfrm>
+            <a:off x="1097280" y="1539277"/>
+            <a:ext cx="4827383" cy="4329817"/>
+          </a:xfrm>
+        </p:spPr>
+        <p:txBody>
+          <a:bodyPr/>
+          <a:lstStyle/>
+          <a:p>
+            <a:r>
+              <a:rPr lang="en-US" dirty="0"/>
+              <a:t>Nested loop</a:t>
+            </a:r>
+          </a:p>
+          <a:p>
+            <a:r>
+              <a:rPr lang="en-US" dirty="0"/>
+              <a:t>Outer loop is not pipelined</a:t>
+            </a:r>
+          </a:p>
+          <a:p>
+            <a:r>
+              <a:rPr lang="en-US" dirty="0"/>
+              <a:t>Must be careful of inner loop pipelining</a:t>
+            </a:r>
+          </a:p>
+          <a:p>
+            <a:endParaRPr lang="en-US" dirty="0"/>
+          </a:p>
+          <a:p>
+            <a:r>
+              <a:rPr lang="en-US" dirty="0"/>
+              <a:t>Will show synthesis reports in class</a:t>
+            </a:r>
+          </a:p>
+        </p:txBody>
+      </p:sp>
+      <p:sp>
+        <p:nvSpPr>
+          <p:cNvPr id="4" name="Slide Number Placeholder 3">
+            <a:extLst>
+              <a:ext uri="{FF2B5EF4-FFF2-40B4-BE49-F238E27FC236}">
+                <a16:creationId xmlns:a16="http://schemas.microsoft.com/office/drawing/2014/main" id="{2E6EA171-F30F-8CBD-26BF-3BC62FEE6076}"/>
+              </a:ext>
+            </a:extLst>
+          </p:cNvPr>
+          <p:cNvSpPr>
+            <a:spLocks noGrp="1"/>
+          </p:cNvSpPr>
+          <p:nvPr>
+            <p:ph type="sldNum" sz="quarter" idx="12"/>
+          </p:nvPr>
+        </p:nvSpPr>
+        <p:spPr/>
+        <p:txBody>
+          <a:bodyPr/>
+          <a:lstStyle/>
+          <a:p>
+            <a:fld id="{629637A9-119A-49DA-BD12-AAC58B377D80}" type="slidenum">
+              <a:rPr lang="en-US" smtClean="0"/>
+              <a:t>44</a:t>
+            </a:fld>
+            <a:endParaRPr lang="en-US" dirty="0"/>
+          </a:p>
+        </p:txBody>
+      </p:sp>
+      <p:pic>
+        <p:nvPicPr>
+          <p:cNvPr id="6" name="Picture 5">
+            <a:extLst>
+              <a:ext uri="{FF2B5EF4-FFF2-40B4-BE49-F238E27FC236}">
+                <a16:creationId xmlns:a16="http://schemas.microsoft.com/office/drawing/2014/main" id="{D646B564-012A-5453-B5C6-CA3CCC7A30A3}"/>
+              </a:ext>
+            </a:extLst>
+          </p:cNvPr>
+          <p:cNvPicPr>
+            <a:picLocks noChangeAspect="1"/>
+          </p:cNvPicPr>
+          <p:nvPr/>
+        </p:nvPicPr>
+        <p:blipFill>
+          <a:blip r:embed="rId2"/>
+          <a:stretch>
+            <a:fillRect/>
+          </a:stretch>
+        </p:blipFill>
+        <p:spPr>
+          <a:xfrm>
+            <a:off x="5856279" y="2057171"/>
+            <a:ext cx="5712061" cy="3385944"/>
+          </a:xfrm>
+          <a:prstGeom prst="rect">
+            <a:avLst/>
+          </a:prstGeom>
+        </p:spPr>
+      </p:pic>
+    </p:spTree>
+    <p:extLst>
+      <p:ext uri="{BB962C8B-B14F-4D97-AF65-F5344CB8AC3E}">
+        <p14:creationId xmlns:p14="http://schemas.microsoft.com/office/powerpoint/2010/main" val="1447276320"/>
+      </p:ext>
+    </p:extLst>
+  </p:cSld>
+  <p:clrMapOvr>
+    <a:masterClrMapping/>
+  </p:clrMapOvr>
+</p:sld>
+</file>
+
+<file path=ppt/slides/slide45.xml><?xml version="1.0" encoding="utf-8"?>
+<p:sld xmlns:a="http://schemas.openxmlformats.org/drawingml/2006/main" xmlns:r="http://schemas.openxmlformats.org/officeDocument/2006/relationships" xmlns:p="http://schemas.openxmlformats.org/presentationml/2006/main">
+  <p:cSld>
+    <p:spTree>
+      <p:nvGrpSpPr>
+        <p:cNvPr id="1" name=""/>
+        <p:cNvGrpSpPr/>
+        <p:nvPr/>
+      </p:nvGrpSpPr>
+      <p:grpSpPr>
+        <a:xfrm>
+          <a:off x="0" y="0"/>
+          <a:ext cx="0" cy="0"/>
+          <a:chOff x="0" y="0"/>
+          <a:chExt cx="0" cy="0"/>
+        </a:xfrm>
+      </p:grpSpPr>
+      <p:sp>
+        <p:nvSpPr>
+          <p:cNvPr id="2" name="Title 1">
+            <a:extLst>
+              <a:ext uri="{FF2B5EF4-FFF2-40B4-BE49-F238E27FC236}">
+                <a16:creationId xmlns:a16="http://schemas.microsoft.com/office/drawing/2014/main" id="{24A02469-7862-1705-5AF6-B46540FF592D}"/>
+              </a:ext>
+            </a:extLst>
+          </p:cNvPr>
+          <p:cNvSpPr>
+            <a:spLocks noGrp="1"/>
+          </p:cNvSpPr>
+          <p:nvPr>
+            <p:ph type="title"/>
+          </p:nvPr>
+        </p:nvSpPr>
+        <p:spPr/>
+        <p:txBody>
+          <a:bodyPr/>
+          <a:lstStyle/>
+          <a:p>
+            <a:r>
+              <a:rPr lang="en-US" dirty="0"/>
+              <a:t>Testbench Memory Allocation</a:t>
+            </a:r>
+          </a:p>
+        </p:txBody>
+      </p:sp>
+      <p:sp>
+        <p:nvSpPr>
+          <p:cNvPr id="3" name="Content Placeholder 2">
+            <a:extLst>
+              <a:ext uri="{FF2B5EF4-FFF2-40B4-BE49-F238E27FC236}">
+                <a16:creationId xmlns:a16="http://schemas.microsoft.com/office/drawing/2014/main" id="{A8AEFD92-215B-DAAC-C427-010253DB4C43}"/>
+              </a:ext>
+            </a:extLst>
+          </p:cNvPr>
+          <p:cNvSpPr>
+            <a:spLocks noGrp="1"/>
+          </p:cNvSpPr>
+          <p:nvPr>
+            <p:ph idx="1"/>
+          </p:nvPr>
+        </p:nvSpPr>
+        <p:spPr>
+          <a:xfrm>
+            <a:off x="265028" y="1539277"/>
+            <a:ext cx="3593754" cy="4329817"/>
+          </a:xfrm>
+        </p:spPr>
+        <p:txBody>
+          <a:bodyPr/>
+          <a:lstStyle/>
+          <a:p>
+            <a:r>
+              <a:rPr lang="en-US" dirty="0"/>
+              <a:t>Testbench creates memory</a:t>
+            </a:r>
+          </a:p>
+          <a:p>
+            <a:r>
+              <a:rPr lang="en-US" dirty="0"/>
+              <a:t>Allocates blocks in memory</a:t>
+            </a:r>
+          </a:p>
+          <a:p>
+            <a:r>
+              <a:rPr lang="en-US" dirty="0"/>
+              <a:t>Computes byte addresses</a:t>
+            </a:r>
+          </a:p>
+        </p:txBody>
+      </p:sp>
+      <p:sp>
+        <p:nvSpPr>
+          <p:cNvPr id="4" name="Slide Number Placeholder 3">
+            <a:extLst>
+              <a:ext uri="{FF2B5EF4-FFF2-40B4-BE49-F238E27FC236}">
+                <a16:creationId xmlns:a16="http://schemas.microsoft.com/office/drawing/2014/main" id="{735FDA94-2EA5-088C-0D76-3F0F9E804495}"/>
+              </a:ext>
+            </a:extLst>
+          </p:cNvPr>
+          <p:cNvSpPr>
+            <a:spLocks noGrp="1"/>
+          </p:cNvSpPr>
+          <p:nvPr>
+            <p:ph type="sldNum" sz="quarter" idx="12"/>
+          </p:nvPr>
+        </p:nvSpPr>
+        <p:spPr/>
+        <p:txBody>
+          <a:bodyPr/>
+          <a:lstStyle/>
+          <a:p>
+            <a:fld id="{629637A9-119A-49DA-BD12-AAC58B377D80}" type="slidenum">
+              <a:rPr lang="en-US" smtClean="0"/>
+              <a:t>45</a:t>
+            </a:fld>
+            <a:endParaRPr lang="en-US" dirty="0"/>
+          </a:p>
+        </p:txBody>
+      </p:sp>
+      <p:pic>
+        <p:nvPicPr>
+          <p:cNvPr id="6" name="Picture 5">
+            <a:extLst>
+              <a:ext uri="{FF2B5EF4-FFF2-40B4-BE49-F238E27FC236}">
+                <a16:creationId xmlns:a16="http://schemas.microsoft.com/office/drawing/2014/main" id="{AB665E0C-1999-D0CC-2297-26AAD769A77B}"/>
+              </a:ext>
+            </a:extLst>
+          </p:cNvPr>
+          <p:cNvPicPr>
+            <a:picLocks noChangeAspect="1"/>
+          </p:cNvPicPr>
+          <p:nvPr/>
+        </p:nvPicPr>
+        <p:blipFill>
+          <a:blip r:embed="rId2"/>
+          <a:stretch>
+            <a:fillRect/>
+          </a:stretch>
+        </p:blipFill>
+        <p:spPr>
+          <a:xfrm>
+            <a:off x="4092571" y="2423212"/>
+            <a:ext cx="7834401" cy="3595431"/>
+          </a:xfrm>
+          <a:prstGeom prst="rect">
+            <a:avLst/>
+          </a:prstGeom>
+        </p:spPr>
+      </p:pic>
+    </p:spTree>
+    <p:extLst>
+      <p:ext uri="{BB962C8B-B14F-4D97-AF65-F5344CB8AC3E}">
+        <p14:creationId xmlns:p14="http://schemas.microsoft.com/office/powerpoint/2010/main" val="3193039582"/>
+      </p:ext>
+    </p:extLst>
+  </p:cSld>
+  <p:clrMapOvr>
+    <a:masterClrMapping/>
+  </p:clrMapOvr>
+</p:sld>
+</file>
+
+<file path=ppt/slides/slide46.xml><?xml version="1.0" encoding="utf-8"?>
+<p:sld xmlns:a="http://schemas.openxmlformats.org/drawingml/2006/main" xmlns:r="http://schemas.openxmlformats.org/officeDocument/2006/relationships" xmlns:p="http://schemas.openxmlformats.org/presentationml/2006/main">
+  <p:cSld>
+    <p:spTree>
+      <p:nvGrpSpPr>
+        <p:cNvPr id="1" name=""/>
+        <p:cNvGrpSpPr/>
+        <p:nvPr/>
+      </p:nvGrpSpPr>
+      <p:grpSpPr>
+        <a:xfrm>
+          <a:off x="0" y="0"/>
+          <a:ext cx="0" cy="0"/>
+          <a:chOff x="0" y="0"/>
+          <a:chExt cx="0" cy="0"/>
+        </a:xfrm>
+      </p:grpSpPr>
+      <p:sp>
+        <p:nvSpPr>
+          <p:cNvPr id="2" name="Title 1">
+            <a:extLst>
+              <a:ext uri="{FF2B5EF4-FFF2-40B4-BE49-F238E27FC236}">
+                <a16:creationId xmlns:a16="http://schemas.microsoft.com/office/drawing/2014/main" id="{1344732E-852F-308D-FC75-71BF2573FE86}"/>
+              </a:ext>
+            </a:extLst>
+          </p:cNvPr>
+          <p:cNvSpPr>
+            <a:spLocks noGrp="1"/>
+          </p:cNvSpPr>
+          <p:nvPr>
+            <p:ph type="title"/>
+          </p:nvPr>
+        </p:nvSpPr>
+        <p:spPr/>
+        <p:txBody>
+          <a:bodyPr/>
+          <a:lstStyle/>
+          <a:p>
+            <a:r>
+              <a:rPr lang="en-US" dirty="0"/>
+              <a:t>Testbench Command</a:t>
+            </a:r>
+          </a:p>
+        </p:txBody>
+      </p:sp>
+      <p:sp>
+        <p:nvSpPr>
+          <p:cNvPr id="3" name="Content Placeholder 2">
+            <a:extLst>
+              <a:ext uri="{FF2B5EF4-FFF2-40B4-BE49-F238E27FC236}">
+                <a16:creationId xmlns:a16="http://schemas.microsoft.com/office/drawing/2014/main" id="{C264517C-7BBB-5D58-C9CF-BE023E989D6D}"/>
+              </a:ext>
+            </a:extLst>
+          </p:cNvPr>
+          <p:cNvSpPr>
+            <a:spLocks noGrp="1"/>
+          </p:cNvSpPr>
+          <p:nvPr>
+            <p:ph idx="1"/>
+          </p:nvPr>
+        </p:nvSpPr>
+        <p:spPr/>
+        <p:txBody>
+          <a:bodyPr/>
+          <a:lstStyle/>
+          <a:p>
+            <a:r>
+              <a:rPr lang="en-US" dirty="0"/>
+              <a:t>Writes addresses in command</a:t>
+            </a:r>
+          </a:p>
+          <a:p>
+            <a:r>
+              <a:rPr lang="en-US" dirty="0"/>
+              <a:t>Upon receipt of response</a:t>
+            </a:r>
+          </a:p>
+          <a:p>
+            <a:pPr lvl="1"/>
+            <a:r>
+              <a:rPr lang="en-US" dirty="0" err="1"/>
+              <a:t>Retieves</a:t>
+            </a:r>
+            <a:r>
+              <a:rPr lang="en-US" dirty="0"/>
+              <a:t> data</a:t>
+            </a:r>
+          </a:p>
+          <a:p>
+            <a:pPr lvl="1"/>
+            <a:r>
+              <a:rPr lang="en-US" dirty="0"/>
+              <a:t>Compares against test vectors </a:t>
+            </a:r>
+          </a:p>
+        </p:txBody>
+      </p:sp>
+      <p:sp>
+        <p:nvSpPr>
+          <p:cNvPr id="4" name="Slide Number Placeholder 3">
+            <a:extLst>
+              <a:ext uri="{FF2B5EF4-FFF2-40B4-BE49-F238E27FC236}">
+                <a16:creationId xmlns:a16="http://schemas.microsoft.com/office/drawing/2014/main" id="{C859AC64-4432-E661-F683-3CC714B68B44}"/>
+              </a:ext>
+            </a:extLst>
+          </p:cNvPr>
+          <p:cNvSpPr>
+            <a:spLocks noGrp="1"/>
+          </p:cNvSpPr>
+          <p:nvPr>
+            <p:ph type="sldNum" sz="quarter" idx="12"/>
+          </p:nvPr>
+        </p:nvSpPr>
+        <p:spPr/>
+        <p:txBody>
+          <a:bodyPr/>
+          <a:lstStyle/>
+          <a:p>
+            <a:fld id="{629637A9-119A-49DA-BD12-AAC58B377D80}" type="slidenum">
+              <a:rPr lang="en-US" smtClean="0"/>
+              <a:t>46</a:t>
+            </a:fld>
+            <a:endParaRPr lang="en-US" dirty="0"/>
+          </a:p>
+        </p:txBody>
+      </p:sp>
+      <p:pic>
+        <p:nvPicPr>
+          <p:cNvPr id="6" name="Picture 5">
+            <a:extLst>
+              <a:ext uri="{FF2B5EF4-FFF2-40B4-BE49-F238E27FC236}">
+                <a16:creationId xmlns:a16="http://schemas.microsoft.com/office/drawing/2014/main" id="{687EADE9-F33F-8CAF-782C-AE29BAE07DF3}"/>
+              </a:ext>
+            </a:extLst>
+          </p:cNvPr>
+          <p:cNvPicPr>
+            <a:picLocks noChangeAspect="1"/>
+          </p:cNvPicPr>
+          <p:nvPr/>
+        </p:nvPicPr>
+        <p:blipFill>
+          <a:blip r:embed="rId2"/>
+          <a:stretch>
+            <a:fillRect/>
+          </a:stretch>
+        </p:blipFill>
+        <p:spPr>
+          <a:xfrm>
+            <a:off x="5613254" y="2155052"/>
+            <a:ext cx="5715181" cy="2936371"/>
+          </a:xfrm>
+          <a:prstGeom prst="rect">
+            <a:avLst/>
+          </a:prstGeom>
+        </p:spPr>
+      </p:pic>
+    </p:spTree>
+    <p:extLst>
+      <p:ext uri="{BB962C8B-B14F-4D97-AF65-F5344CB8AC3E}">
+        <p14:creationId xmlns:p14="http://schemas.microsoft.com/office/powerpoint/2010/main" val="1671194138"/>
+      </p:ext>
+    </p:extLst>
+  </p:cSld>
+  <p:clrMapOvr>
+    <a:masterClrMapping/>
+  </p:clrMapOvr>
+</p:sld>
+</file>
+
+<file path=ppt/slides/slide47.xml><?xml version="1.0" encoding="utf-8"?>
+<p:sld xmlns:a="http://schemas.openxmlformats.org/drawingml/2006/main" xmlns:r="http://schemas.openxmlformats.org/officeDocument/2006/relationships" xmlns:p="http://schemas.openxmlformats.org/presentationml/2006/main">
+  <p:cSld>
+    <p:spTree>
+      <p:nvGrpSpPr>
+        <p:cNvPr id="1" name=""/>
+        <p:cNvGrpSpPr/>
+        <p:nvPr/>
+      </p:nvGrpSpPr>
+      <p:grpSpPr>
+        <a:xfrm>
+          <a:off x="0" y="0"/>
+          <a:ext cx="0" cy="0"/>
+          <a:chOff x="0" y="0"/>
+          <a:chExt cx="0" cy="0"/>
+        </a:xfrm>
+      </p:grpSpPr>
+      <p:sp>
+        <p:nvSpPr>
+          <p:cNvPr id="2" name="Title 1">
+            <a:extLst>
+              <a:ext uri="{FF2B5EF4-FFF2-40B4-BE49-F238E27FC236}">
+                <a16:creationId xmlns:a16="http://schemas.microsoft.com/office/drawing/2014/main" id="{7DABD633-618D-FC99-14E9-E106A48772C5}"/>
+              </a:ext>
+            </a:extLst>
+          </p:cNvPr>
+          <p:cNvSpPr>
+            <a:spLocks noGrp="1"/>
+          </p:cNvSpPr>
+          <p:nvPr>
+            <p:ph type="title"/>
+          </p:nvPr>
+        </p:nvSpPr>
+        <p:spPr/>
+        <p:txBody>
+          <a:bodyPr/>
+          <a:lstStyle/>
+          <a:p>
+            <a:r>
+              <a:rPr lang="en-US" dirty="0"/>
+              <a:t>Timing:  Read Phases</a:t>
+            </a:r>
+          </a:p>
+        </p:txBody>
+      </p:sp>
+      <p:sp>
+        <p:nvSpPr>
+          <p:cNvPr id="3" name="Content Placeholder 2">
+            <a:extLst>
+              <a:ext uri="{FF2B5EF4-FFF2-40B4-BE49-F238E27FC236}">
+                <a16:creationId xmlns:a16="http://schemas.microsoft.com/office/drawing/2014/main" id="{BBFF7C5D-EDDF-D311-F24A-ECB28F06E1D3}"/>
+              </a:ext>
+            </a:extLst>
+          </p:cNvPr>
+          <p:cNvSpPr>
+            <a:spLocks noGrp="1"/>
+          </p:cNvSpPr>
+          <p:nvPr>
+            <p:ph idx="1"/>
+          </p:nvPr>
+        </p:nvSpPr>
+        <p:spPr/>
+        <p:txBody>
+          <a:bodyPr/>
+          <a:lstStyle/>
+          <a:p>
+            <a:r>
+              <a:rPr lang="en-US" dirty="0"/>
+              <a:t>Test parameters</a:t>
+            </a:r>
+          </a:p>
+          <a:p>
+            <a:pPr lvl="1"/>
+            <a:r>
+              <a:rPr lang="en-US" dirty="0"/>
+              <a:t>7 bins</a:t>
+            </a:r>
+          </a:p>
+          <a:p>
+            <a:pPr lvl="1"/>
+            <a:r>
+              <a:rPr lang="en-US" dirty="0"/>
+              <a:t>37 data points</a:t>
+            </a:r>
+          </a:p>
+          <a:p>
+            <a:r>
+              <a:rPr lang="en-US" dirty="0"/>
+              <a:t>Partitioning</a:t>
+            </a:r>
+          </a:p>
+          <a:p>
+            <a:pPr lvl="1"/>
+            <a:r>
+              <a:rPr lang="en-US" dirty="0"/>
+              <a:t>Data broken into three busts</a:t>
+            </a:r>
+          </a:p>
+          <a:p>
+            <a:pPr lvl="1"/>
+            <a:r>
+              <a:rPr lang="en-US" dirty="0"/>
+              <a:t>16, 16, and 5</a:t>
+            </a:r>
+          </a:p>
+          <a:p>
+            <a:pPr lvl="1"/>
+            <a:r>
+              <a:rPr lang="en-US" dirty="0"/>
+              <a:t>Requests given at beginning</a:t>
+            </a:r>
+          </a:p>
+        </p:txBody>
+      </p:sp>
+      <p:sp>
+        <p:nvSpPr>
+          <p:cNvPr id="4" name="Slide Number Placeholder 3">
+            <a:extLst>
+              <a:ext uri="{FF2B5EF4-FFF2-40B4-BE49-F238E27FC236}">
+                <a16:creationId xmlns:a16="http://schemas.microsoft.com/office/drawing/2014/main" id="{0602DFCE-FBBD-C07F-12E6-3FBBF5837593}"/>
+              </a:ext>
+            </a:extLst>
+          </p:cNvPr>
+          <p:cNvSpPr>
+            <a:spLocks noGrp="1"/>
+          </p:cNvSpPr>
+          <p:nvPr>
+            <p:ph type="sldNum" sz="quarter" idx="12"/>
+          </p:nvPr>
+        </p:nvSpPr>
+        <p:spPr/>
+        <p:txBody>
+          <a:bodyPr/>
+          <a:lstStyle/>
+          <a:p>
+            <a:fld id="{629637A9-119A-49DA-BD12-AAC58B377D80}" type="slidenum">
+              <a:rPr lang="en-US" smtClean="0"/>
+              <a:t>47</a:t>
+            </a:fld>
+            <a:endParaRPr lang="en-US" dirty="0"/>
+          </a:p>
+        </p:txBody>
+      </p:sp>
+      <p:pic>
+        <p:nvPicPr>
+          <p:cNvPr id="6" name="Picture 5">
+            <a:extLst>
+              <a:ext uri="{FF2B5EF4-FFF2-40B4-BE49-F238E27FC236}">
+                <a16:creationId xmlns:a16="http://schemas.microsoft.com/office/drawing/2014/main" id="{A60410C1-E000-903E-38D9-434FE66A6E1F}"/>
+              </a:ext>
+            </a:extLst>
+          </p:cNvPr>
+          <p:cNvPicPr>
+            <a:picLocks noChangeAspect="1"/>
+          </p:cNvPicPr>
+          <p:nvPr/>
+        </p:nvPicPr>
+        <p:blipFill>
+          <a:blip r:embed="rId2"/>
+          <a:srcRect t="39039"/>
+          <a:stretch>
+            <a:fillRect/>
+          </a:stretch>
+        </p:blipFill>
+        <p:spPr>
+          <a:xfrm>
+            <a:off x="4537282" y="1874791"/>
+            <a:ext cx="7128456" cy="3698180"/>
+          </a:xfrm>
+          <a:prstGeom prst="rect">
+            <a:avLst/>
+          </a:prstGeom>
+        </p:spPr>
+      </p:pic>
+    </p:spTree>
+    <p:extLst>
+      <p:ext uri="{BB962C8B-B14F-4D97-AF65-F5344CB8AC3E}">
+        <p14:creationId xmlns:p14="http://schemas.microsoft.com/office/powerpoint/2010/main" val="1489991469"/>
       </p:ext>
     </p:extLst>
   </p:cSld>

</xml_diff>